<commit_message>
updating figures and text.
</commit_message>
<xml_diff>
--- a/Documentation/Reports and Papers/Dissertation/Figures/60-sns/components/pipeline.pptx
+++ b/Documentation/Reports and Papers/Dissertation/Figures/60-sns/components/pipeline.pptx
@@ -3140,7 +3140,7 @@
         </p:nvSpPr>
         <p:spPr>
           <a:xfrm>
-            <a:off x="54000" y="198000"/>
+            <a:off x="54000" y="223200"/>
             <a:ext cx="1458000" cy="270000"/>
           </a:xfrm>
           <a:prstGeom prst="rect">
@@ -3219,7 +3219,7 @@
         </p:nvSpPr>
         <p:spPr>
           <a:xfrm>
-            <a:off x="1710000" y="198000"/>
+            <a:off x="1710000" y="223200"/>
             <a:ext cx="2178000" cy="270000"/>
           </a:xfrm>
           <a:prstGeom prst="rect">
@@ -3298,7 +3298,7 @@
         </p:nvSpPr>
         <p:spPr>
           <a:xfrm>
-            <a:off x="4086000" y="198000"/>
+            <a:off x="4086000" y="223200"/>
             <a:ext cx="2052000" cy="270000"/>
           </a:xfrm>
           <a:prstGeom prst="rect">
@@ -3966,7 +3966,7 @@
                 </a:solidFill>
                 <a:latin typeface="Arial"/>
               </a:rPr>
-              <a:t>SNS network evaluation</a:t>
+              <a:t>network evaluation</a:t>
             </a:r>
           </a:p>
         </p:txBody>
@@ -4034,7 +4034,7 @@
                 </a:solidFill>
                 <a:latin typeface="Arial"/>
               </a:rPr>
-              <a:t>per-joint valve, pressure,</a:t>
+              <a:t>valve, pressure, and</a:t>
             </a:r>
           </a:p>
           <a:p>
@@ -4046,7 +4046,7 @@
                 </a:solidFill>
                 <a:latin typeface="Arial"/>
               </a:rPr>
-              <a:t>and contact loops</a:t>
+              <a:t>contact loops</a:t>
             </a:r>
           </a:p>
         </p:txBody>
@@ -4293,8 +4293,8 @@
         </p:nvSpPr>
         <p:spPr>
           <a:xfrm>
-            <a:off x="3348000" y="1854000"/>
-            <a:ext cx="990000" cy="270000"/>
+            <a:off x="3131999" y="1854000"/>
+            <a:ext cx="827999" cy="270000"/>
           </a:xfrm>
           <a:prstGeom prst="rect">
             <a:avLst/>
@@ -4540,8 +4540,8 @@
         </p:nvSpPr>
         <p:spPr>
           <a:xfrm>
-            <a:off x="792000" y="2628000"/>
-            <a:ext cx="4500000" cy="270000"/>
+            <a:off x="108000" y="2628000"/>
+            <a:ext cx="5976000" cy="270000"/>
           </a:xfrm>
           <a:prstGeom prst="rect">
             <a:avLst/>
@@ -4562,7 +4562,19 @@
                 </a:solidFill>
                 <a:latin typeface="Arial"/>
               </a:rPr>
-              <a:t>Computer-in-the-loop: the embedded stack first executes against the simulated body, then against the physical one.</a:t>
+              <a:t>Computer-in-the-loop: the embedded stack first executes against</a:t>
+            </a:r>
+          </a:p>
+          <a:p>
+            <a:pPr algn="ctr"/>
+            <a:r>
+              <a:rPr sz="1000" b="0">
+                <a:solidFill>
+                  <a:srgbClr val="1F1F1F"/>
+                </a:solidFill>
+                <a:latin typeface="Arial"/>
+              </a:rPr>
+              <a:t>the simulated body, then against the physical one.</a:t>
             </a:r>
           </a:p>
         </p:txBody>

</xml_diff>